<commit_message>
Simplifica la terminología: sin Brier, lift ni ablaciones; intervalos de confianza y validación cruzada en lenguaje llano
</commit_message>
<xml_diff>
--- a/docs/Presentacion_Final_Proyecto_Integrador.pptx
+++ b/docs/Presentacion_Final_Proyecto_Integrador.pptx
@@ -7426,7 +7426,7 @@
                   <a:schemeClr val="tx1"/>
                 </a:solidFill>
               </a:rPr>
-              <a:t>Test único de 1.127 clientes + intervalos por bootstrap.</a:t>
+              <a:t>Test único de 1.127 clientes + intervalos de confianza.</a:t>
             </a:r>
             <a:endParaRPr lang="en-US" sz="1400" dirty="0"/>
           </a:p>
@@ -8635,7 +8635,7 @@
                   <a:schemeClr val="tx1"/>
                 </a:solidFill>
               </a:rPr>
-              <a:t>Los cinco quedan dentro del margen de error (validación cruzada y bootstrap).</a:t>
+              <a:t>Los cinco quedan dentro del margen de error (validación cruzada e intervalos de confianza).</a:t>
             </a:r>
             <a:endParaRPr lang="en-US" sz="1600" dirty="0"/>
           </a:p>

</xml_diff>

<commit_message>
Valor del cliente: priorización por valor en riesgo y escenarios de costo por cliente retenido (USD 100, 1.000, 10.000)
</commit_message>
<xml_diff>
--- a/docs/Presentacion_Final_Proyecto_Integrador.pptx
+++ b/docs/Presentacion_Final_Proyecto_Integrador.pptx
@@ -3293,7 +3293,7 @@
           <a:p>
             <a:r>
               <a:rPr lang="en-US" dirty="0"/>
-              <a:t>La tasa de éxito de la acción de retención es el supuesto que más mueve el resultado y es justamente lo que el piloto debe medir.</a:t>
+              <a:t>Retener suele ser más barato que conseguir un cliente nuevo, pero solo con los clientes que valen la pena. El cliente retenido promedio vale unos USD 2.100: hasta ese costo conviene retener.</a:t>
             </a:r>
             <a:endParaRPr lang="en-US" dirty="0"/>
           </a:p>
@@ -9766,7 +9766,7 @@
                   <a:schemeClr val="tx2"/>
                 </a:solidFill>
               </a:rPr>
-              <a:t>Impacto: mismo presupuesto, más clientes retenidos</a:t>
+              <a:t>Retener conviene si cuesta menos de lo que vale el cliente</a:t>
             </a:r>
             <a:endParaRPr lang="en-US" sz="3200" dirty="0"/>
           </a:p>
@@ -9780,7 +9780,7 @@
         </p:nvSpPr>
         <p:spPr>
           <a:xfrm>
-            <a:off x="548640" y="1371600"/>
+            <a:off x="548640" y="1325880"/>
             <a:ext cx="11064240" cy="457200"/>
           </a:xfrm>
           <a:prstGeom prst="rect">
@@ -9802,7 +9802,7 @@
                   <a:schemeClr val="tx1"/>
                 </a:solidFill>
               </a:rPr>
-              <a:t>Por cada 10.000 clientes, frente a llamar al azar:</a:t>
+              <a:t>Valor neto preservado por cada 10.000 clientes (valor de los retenidos menos el costo de retenerlos):</a:t>
             </a:r>
             <a:endParaRPr lang="en-US" sz="1800" dirty="0"/>
           </a:p>
@@ -9816,12 +9816,12 @@
         </p:nvSpPr>
         <p:spPr>
           <a:xfrm>
-            <a:off x="548640" y="2011680"/>
-            <a:ext cx="3520440" cy="2377440"/>
+            <a:off x="548640" y="1965960"/>
+            <a:ext cx="3520440" cy="2606040"/>
           </a:xfrm>
           <a:prstGeom prst="roundRect">
             <a:avLst>
-              <a:gd name="adj" fmla="val 4615"/>
+              <a:gd name="adj" fmla="val 4211"/>
             </a:avLst>
           </a:prstGeom>
           <a:solidFill>
@@ -9839,14 +9839,14 @@
       </p:sp>
       <p:sp>
         <p:nvSpPr>
-          <p:cNvPr id="5" name="imp-0-num"/>
+          <p:cNvPr id="5" name="imp-c-0"/>
           <p:cNvSpPr txBox="1"/>
           <p:nvPr/>
         </p:nvSpPr>
         <p:spPr>
           <a:xfrm>
-            <a:off x="822960" y="2240280"/>
-            <a:ext cx="3017520" cy="914400"/>
+            <a:off x="822960" y="2148840"/>
+            <a:ext cx="3017520" cy="411480"/>
           </a:xfrm>
           <a:prstGeom prst="rect">
             <a:avLst/>
@@ -9862,27 +9862,63 @@
               <a:buNone/>
             </a:pPr>
             <a:r>
-              <a:rPr lang="en-US" sz="4000" b="1" dirty="0">
+              <a:rPr lang="en-US" sz="1500" b="1" dirty="0">
+                <a:solidFill>
+                  <a:schemeClr val="tx2"/>
+                </a:solidFill>
+              </a:rPr>
+              <a:t>Costo por retenido: USD 100</a:t>
+            </a:r>
+            <a:endParaRPr lang="en-US" sz="1500" dirty="0"/>
+          </a:p>
+        </p:txBody>
+      </p:sp>
+      <p:sp>
+        <p:nvSpPr>
+          <p:cNvPr id="6" name="imp-v-0"/>
+          <p:cNvSpPr txBox="1"/>
+          <p:nvPr/>
+        </p:nvSpPr>
+        <p:spPr>
+          <a:xfrm>
+            <a:off x="822960" y="2651760"/>
+            <a:ext cx="3017520" cy="822960"/>
+          </a:xfrm>
+          <a:prstGeom prst="rect">
+            <a:avLst/>
+          </a:prstGeom>
+          <a:noFill/>
+          <a:ln/>
+        </p:spPr>
+        <p:txBody>
+          <a:bodyPr wrap="square" lIns="0" tIns="0" rIns="0" bIns="0" rtlCol="0" anchor="ctr"/>
+          <a:lstStyle/>
+          <a:p>
+            <a:pPr indent="0" marL="0">
+              <a:buNone/>
+            </a:pPr>
+            <a:r>
+              <a:rPr lang="en-US" sz="3800" b="1" dirty="0">
                 <a:solidFill>
                   <a:schemeClr val="accent1"/>
                 </a:solidFill>
               </a:rPr>
-              <a:t>+879</a:t>
-            </a:r>
-            <a:endParaRPr lang="en-US" sz="4000" dirty="0"/>
-          </a:p>
-        </p:txBody>
-      </p:sp>
-      <p:sp>
-        <p:nvSpPr>
-          <p:cNvPr id="6" name="imp-0-txt"/>
+              <a:t>USD 824 mil</a:t>
+            </a:r>
+            <a:endParaRPr lang="en-US" sz="3800" dirty="0"/>
+          </a:p>
+        </p:txBody>
+      </p:sp>
+      <p:sp>
+        <p:nvSpPr>
+          <p:cNvPr id="7" name="imp-t-0"/>
           <p:cNvSpPr txBox="1"/>
           <p:nvPr/>
         </p:nvSpPr>
         <p:spPr>
           <a:xfrm>
-            <a:off x="822960" y="3200400"/>
-            <a:ext cx="3017520" cy="822960"/>
+            <a:off x="822960" y="3520440"/>
+            <a:ext cx="3017520" cy="868680"/>
           </a:xfrm>
           <a:prstGeom prst="rect">
             <a:avLst/>
@@ -9898,31 +9934,31 @@
               <a:buNone/>
             </a:pPr>
             <a:r>
-              <a:rPr lang="en-US" sz="1600" dirty="0">
+              <a:rPr lang="en-US" sz="1500" dirty="0">
                 <a:solidFill>
                   <a:schemeClr val="tx1"/>
                 </a:solidFill>
               </a:rPr>
-              <a:t>abandonos detectados de más en cada campaña</a:t>
-            </a:r>
-            <a:endParaRPr lang="en-US" sz="1600" dirty="0"/>
-          </a:p>
-        </p:txBody>
-      </p:sp>
-      <p:sp>
-        <p:nvSpPr>
-          <p:cNvPr id="7" name="imp-1"/>
+              <a:t>priorizando por valor en riesgo (al azar: USD 276 mil)</a:t>
+            </a:r>
+            <a:endParaRPr lang="en-US" sz="1500" dirty="0"/>
+          </a:p>
+        </p:txBody>
+      </p:sp>
+      <p:sp>
+        <p:nvSpPr>
+          <p:cNvPr id="8" name="imp-1"/>
           <p:cNvSpPr/>
           <p:nvPr/>
         </p:nvSpPr>
         <p:spPr>
           <a:xfrm>
-            <a:off x="4343400" y="2011680"/>
-            <a:ext cx="3520440" cy="2377440"/>
+            <a:off x="4343400" y="1965960"/>
+            <a:ext cx="3520440" cy="2606040"/>
           </a:xfrm>
           <a:prstGeom prst="roundRect">
             <a:avLst>
-              <a:gd name="adj" fmla="val 4615"/>
+              <a:gd name="adj" fmla="val 4211"/>
             </a:avLst>
           </a:prstGeom>
           <a:solidFill>
@@ -9940,14 +9976,14 @@
       </p:sp>
       <p:sp>
         <p:nvSpPr>
-          <p:cNvPr id="8" name="imp-1-num"/>
+          <p:cNvPr id="9" name="imp-c-1"/>
           <p:cNvSpPr txBox="1"/>
           <p:nvPr/>
         </p:nvSpPr>
         <p:spPr>
           <a:xfrm>
-            <a:off x="4617720" y="2240280"/>
-            <a:ext cx="3017520" cy="914400"/>
+            <a:off x="4617720" y="2148840"/>
+            <a:ext cx="3017520" cy="411480"/>
           </a:xfrm>
           <a:prstGeom prst="rect">
             <a:avLst/>
@@ -9963,27 +9999,63 @@
               <a:buNone/>
             </a:pPr>
             <a:r>
-              <a:rPr lang="en-US" sz="4000" b="1" dirty="0">
+              <a:rPr lang="en-US" sz="1500" b="1" dirty="0">
+                <a:solidFill>
+                  <a:schemeClr val="tx2"/>
+                </a:solidFill>
+              </a:rPr>
+              <a:t>Costo por retenido: USD 1.000</a:t>
+            </a:r>
+            <a:endParaRPr lang="en-US" sz="1500" dirty="0"/>
+          </a:p>
+        </p:txBody>
+      </p:sp>
+      <p:sp>
+        <p:nvSpPr>
+          <p:cNvPr id="10" name="imp-v-1"/>
+          <p:cNvSpPr txBox="1"/>
+          <p:nvPr/>
+        </p:nvSpPr>
+        <p:spPr>
+          <a:xfrm>
+            <a:off x="4617720" y="2651760"/>
+            <a:ext cx="3017520" cy="822960"/>
+          </a:xfrm>
+          <a:prstGeom prst="rect">
+            <a:avLst/>
+          </a:prstGeom>
+          <a:noFill/>
+          <a:ln/>
+        </p:spPr>
+        <p:txBody>
+          <a:bodyPr wrap="square" lIns="0" tIns="0" rIns="0" bIns="0" rtlCol="0" anchor="ctr"/>
+          <a:lstStyle/>
+          <a:p>
+            <a:pPr indent="0" marL="0">
+              <a:buNone/>
+            </a:pPr>
+            <a:r>
+              <a:rPr lang="en-US" sz="3800" b="1" dirty="0">
                 <a:solidFill>
                   <a:schemeClr val="accent1"/>
                 </a:solidFill>
               </a:rPr>
-              <a:t>+264</a:t>
-            </a:r>
-            <a:endParaRPr lang="en-US" sz="4000" dirty="0"/>
-          </a:p>
-        </p:txBody>
-      </p:sp>
-      <p:sp>
-        <p:nvSpPr>
-          <p:cNvPr id="9" name="imp-1-txt"/>
+              <a:t>USD 455 mil</a:t>
+            </a:r>
+            <a:endParaRPr lang="en-US" sz="3800" dirty="0"/>
+          </a:p>
+        </p:txBody>
+      </p:sp>
+      <p:sp>
+        <p:nvSpPr>
+          <p:cNvPr id="11" name="imp-t-1"/>
           <p:cNvSpPr txBox="1"/>
           <p:nvPr/>
         </p:nvSpPr>
         <p:spPr>
           <a:xfrm>
-            <a:off x="4617720" y="3200400"/>
-            <a:ext cx="3017520" cy="822960"/>
+            <a:off x="4617720" y="3520440"/>
+            <a:ext cx="3017520" cy="868680"/>
           </a:xfrm>
           <a:prstGeom prst="rect">
             <a:avLst/>
@@ -9999,31 +10071,31 @@
               <a:buNone/>
             </a:pPr>
             <a:r>
-              <a:rPr lang="en-US" sz="1600" dirty="0">
+              <a:rPr lang="en-US" sz="1500" dirty="0">
                 <a:solidFill>
                   <a:schemeClr val="tx1"/>
                 </a:solidFill>
               </a:rPr>
-              <a:t>clientes retenidos esperados</a:t>
-            </a:r>
-            <a:endParaRPr lang="en-US" sz="1600" dirty="0"/>
-          </a:p>
-        </p:txBody>
-      </p:sp>
-      <p:sp>
-        <p:nvSpPr>
-          <p:cNvPr id="10" name="imp-2"/>
+              <a:t>priorizando por valor en riesgo (al azar: USD 190 mil)</a:t>
+            </a:r>
+            <a:endParaRPr lang="en-US" sz="1500" dirty="0"/>
+          </a:p>
+        </p:txBody>
+      </p:sp>
+      <p:sp>
+        <p:nvSpPr>
+          <p:cNvPr id="12" name="imp-2"/>
           <p:cNvSpPr/>
           <p:nvPr/>
         </p:nvSpPr>
         <p:spPr>
           <a:xfrm>
-            <a:off x="8138160" y="2011680"/>
-            <a:ext cx="3520440" cy="2377440"/>
+            <a:off x="8138160" y="1965960"/>
+            <a:ext cx="3520440" cy="2606040"/>
           </a:xfrm>
           <a:prstGeom prst="roundRect">
             <a:avLst>
-              <a:gd name="adj" fmla="val 4615"/>
+              <a:gd name="adj" fmla="val 4211"/>
             </a:avLst>
           </a:prstGeom>
           <a:solidFill>
@@ -10041,14 +10113,14 @@
       </p:sp>
       <p:sp>
         <p:nvSpPr>
-          <p:cNvPr id="11" name="imp-2-num"/>
+          <p:cNvPr id="13" name="imp-c-2"/>
           <p:cNvSpPr txBox="1"/>
           <p:nvPr/>
         </p:nvSpPr>
         <p:spPr>
           <a:xfrm>
-            <a:off x="8412480" y="2240280"/>
-            <a:ext cx="3017520" cy="914400"/>
+            <a:off x="8412480" y="2148840"/>
+            <a:ext cx="3017520" cy="411480"/>
           </a:xfrm>
           <a:prstGeom prst="rect">
             <a:avLst/>
@@ -10064,27 +10136,63 @@
               <a:buNone/>
             </a:pPr>
             <a:r>
-              <a:rPr lang="en-US" sz="4000" b="1" dirty="0">
+              <a:rPr lang="en-US" sz="1500" b="1" dirty="0">
+                <a:solidFill>
+                  <a:schemeClr val="tx2"/>
+                </a:solidFill>
+              </a:rPr>
+              <a:t>Costo por retenido: USD 10.000</a:t>
+            </a:r>
+            <a:endParaRPr lang="en-US" sz="1500" dirty="0"/>
+          </a:p>
+        </p:txBody>
+      </p:sp>
+      <p:sp>
+        <p:nvSpPr>
+          <p:cNvPr id="14" name="imp-v-2"/>
+          <p:cNvSpPr txBox="1"/>
+          <p:nvPr/>
+        </p:nvSpPr>
+        <p:spPr>
+          <a:xfrm>
+            <a:off x="8412480" y="2651760"/>
+            <a:ext cx="3017520" cy="822960"/>
+          </a:xfrm>
+          <a:prstGeom prst="rect">
+            <a:avLst/>
+          </a:prstGeom>
+          <a:noFill/>
+          <a:ln/>
+        </p:spPr>
+        <p:txBody>
+          <a:bodyPr wrap="square" lIns="0" tIns="0" rIns="0" bIns="0" rtlCol="0" anchor="ctr"/>
+          <a:lstStyle/>
+          <a:p>
+            <a:pPr indent="0" marL="0">
+              <a:buNone/>
+            </a:pPr>
+            <a:r>
+              <a:rPr lang="en-US" sz="3800" b="1" dirty="0">
                 <a:solidFill>
                   <a:schemeClr val="accent2"/>
                 </a:solidFill>
               </a:rPr>
-              <a:t>USD 276 mil</a:t>
-            </a:r>
-            <a:endParaRPr lang="en-US" sz="4000" dirty="0"/>
-          </a:p>
-        </p:txBody>
-      </p:sp>
-      <p:sp>
-        <p:nvSpPr>
-          <p:cNvPr id="12" name="imp-2-txt"/>
+              <a:t>No conviene</a:t>
+            </a:r>
+            <a:endParaRPr lang="en-US" sz="3800" dirty="0"/>
+          </a:p>
+        </p:txBody>
+      </p:sp>
+      <p:sp>
+        <p:nvSpPr>
+          <p:cNvPr id="15" name="imp-t-2"/>
           <p:cNvSpPr txBox="1"/>
           <p:nvPr/>
         </p:nvSpPr>
         <p:spPr>
           <a:xfrm>
-            <a:off x="8412480" y="3200400"/>
-            <a:ext cx="3017520" cy="822960"/>
+            <a:off x="8412480" y="3520440"/>
+            <a:ext cx="3017520" cy="868680"/>
           </a:xfrm>
           <a:prstGeom prst="rect">
             <a:avLst/>
@@ -10100,12 +10208,59 @@
               <a:buNone/>
             </a:pPr>
             <a:r>
+              <a:rPr lang="en-US" sz="1500" dirty="0">
+                <a:solidFill>
+                  <a:schemeClr val="tx1"/>
+                </a:solidFill>
+              </a:rPr>
+              <a:t>ningún cliente vale tanto: conviene invertir en clientes nuevos</a:t>
+            </a:r>
+            <a:endParaRPr lang="en-US" sz="1500" dirty="0"/>
+          </a:p>
+        </p:txBody>
+      </p:sp>
+      <p:sp>
+        <p:nvSpPr>
+          <p:cNvPr id="16" name="imp-supuestos"/>
+          <p:cNvSpPr txBox="1"/>
+          <p:nvPr/>
+        </p:nvSpPr>
+        <p:spPr>
+          <a:xfrm>
+            <a:off x="548640" y="4846320"/>
+            <a:ext cx="11064240" cy="731520"/>
+          </a:xfrm>
+          <a:prstGeom prst="rect">
+            <a:avLst/>
+          </a:prstGeom>
+          <a:noFill/>
+          <a:ln/>
+        </p:spPr>
+        <p:txBody>
+          <a:bodyPr wrap="square" lIns="0" tIns="0" rIns="0" bIns="0" rtlCol="0" anchor="ctr"/>
+          <a:lstStyle/>
+          <a:p>
+            <a:pPr indent="0" marL="0">
+              <a:buNone/>
+            </a:pPr>
+            <a:r>
+              <a:rPr lang="en-US" sz="1600" b="1" dirty="0">
+                <a:solidFill>
+                  <a:schemeClr val="tx1"/>
+                </a:solidFill>
+              </a:rPr>
+              <a:t>Supuestos genéricos: </a:t>
+            </a:r>
+            <a:pPr indent="0" marL="0">
+              <a:buNone/>
+            </a:pPr>
+            <a:r>
               <a:rPr lang="en-US" sz="1600" dirty="0">
                 <a:solidFill>
                   <a:schemeClr val="tx1"/>
                 </a:solidFill>
               </a:rPr>
-              <a:t>más de beneficio neto anual</a:t>
+              <a:t>valor del cliente = cargo mensual × 24 meses; se retiene al 30 % de los contactados que iban a irse; solo se contacta a quien vale más que su costo de retención.</a:t>
             </a:r>
             <a:endParaRPr lang="en-US" sz="1600" dirty="0"/>
           </a:p>
@@ -10113,14 +10268,14 @@
       </p:sp>
       <p:sp>
         <p:nvSpPr>
-          <p:cNvPr id="13" name="imp-supuestos"/>
+          <p:cNvPr id="17" name="imp-auto"/>
           <p:cNvSpPr txBox="1"/>
           <p:nvPr/>
         </p:nvSpPr>
         <p:spPr>
           <a:xfrm>
-            <a:off x="548640" y="4663440"/>
-            <a:ext cx="11064240" cy="822960"/>
+            <a:off x="548640" y="5623560"/>
+            <a:ext cx="11064240" cy="548640"/>
           </a:xfrm>
           <a:prstGeom prst="rect">
             <a:avLst/>
@@ -10138,57 +10293,10 @@
             <a:r>
               <a:rPr lang="en-US" sz="1600" b="1" dirty="0">
                 <a:solidFill>
-                  <a:schemeClr val="tx1"/>
-                </a:solidFill>
-              </a:rPr>
-              <a:t>Supuestos para reemplazar con datos reales: </a:t>
-            </a:r>
-            <a:pPr indent="0" marL="0">
-              <a:buNone/>
-            </a:pPr>
-            <a:r>
-              <a:rPr lang="en-US" sz="1600" dirty="0">
-                <a:solidFill>
-                  <a:schemeClr val="tx1"/>
-                </a:solidFill>
-              </a:rPr>
-              <a:t>USD 15 por contacto, 30 % de éxito de la acción de retención y 12 meses de facturación preservada. Con 15 % de éxito el beneficio del modelo es USD 181 mil; con 45 %, USD 604 mil.</a:t>
-            </a:r>
-            <a:endParaRPr lang="en-US" sz="1600" dirty="0"/>
-          </a:p>
-        </p:txBody>
-      </p:sp>
-      <p:sp>
-        <p:nvSpPr>
-          <p:cNvPr id="14" name="imp-auto"/>
-          <p:cNvSpPr txBox="1"/>
-          <p:nvPr/>
-        </p:nvSpPr>
-        <p:spPr>
-          <a:xfrm>
-            <a:off x="548640" y="5532120"/>
-            <a:ext cx="11064240" cy="640080"/>
-          </a:xfrm>
-          <a:prstGeom prst="rect">
-            <a:avLst/>
-          </a:prstGeom>
-          <a:noFill/>
-          <a:ln/>
-        </p:spPr>
-        <p:txBody>
-          <a:bodyPr wrap="square" lIns="0" tIns="0" rIns="0" bIns="0" rtlCol="0" anchor="ctr"/>
-          <a:lstStyle/>
-          <a:p>
-            <a:pPr indent="0" marL="0">
-              <a:buNone/>
-            </a:pPr>
-            <a:r>
-              <a:rPr lang="en-US" sz="1600" b="1" dirty="0">
-                <a:solidFill>
                   <a:schemeClr val="tx2"/>
                 </a:solidFill>
               </a:rPr>
-              <a:t>Además automatiza la selección: hoy no hay criterio; con el modelo, la lista priorizada se genera en segundos antes de cada campaña.</a:t>
+              <a:t>Priorizar por valor en riesgo (probabilidad × valor) rescata a los que se van y además gastan mucho.</a:t>
             </a:r>
             <a:endParaRPr lang="en-US" sz="1600" dirty="0"/>
           </a:p>

</xml_diff>

<commit_message>
Segmentación por valor y riesgo (Golden, Champions), ciclo de vida, CAC y retener frente a adquirir; dimensionamiento del piloto
</commit_message>
<xml_diff>
--- a/docs/Presentacion_Final_Proyecto_Integrador.pptx
+++ b/docs/Presentacion_Final_Proyecto_Integrador.pptx
@@ -3293,7 +3293,7 @@
           <a:p>
             <a:r>
               <a:rPr lang="en-US" dirty="0"/>
-              <a:t>Retener suele ser más barato que conseguir un cliente nuevo, pero solo con los clientes que valen la pena. El cliente retenido promedio vale unos USD 2.100: hasta ese costo conviene retener.</a:t>
+              <a:t>No todos los clientes se rescatan por igual. Los Golden se van y además gastan mucho: ahí se justifica invertir. La cuenta es simple: retener tiene que costar menos que dejarlo ir y conseguir uno nuevo con publicidad.</a:t>
             </a:r>
             <a:endParaRPr lang="en-US" dirty="0"/>
           </a:p>
@@ -9766,7 +9766,7 @@
                   <a:schemeClr val="tx2"/>
                 </a:solidFill>
               </a:rPr>
-              <a:t>Retener conviene si cuesta menos de lo que vale el cliente</a:t>
+              <a:t>Rescatar Golden cuesta menos que captar clientes</a:t>
             </a:r>
             <a:endParaRPr lang="en-US" sz="3200" dirty="0"/>
           </a:p>
@@ -9774,58 +9774,22 @@
       </p:sp>
       <p:sp>
         <p:nvSpPr>
-          <p:cNvPr id="3" name="imp-intro"/>
-          <p:cNvSpPr txBox="1"/>
-          <p:nvPr/>
-        </p:nvSpPr>
-        <p:spPr>
-          <a:xfrm>
-            <a:off x="548640" y="1325880"/>
-            <a:ext cx="11064240" cy="457200"/>
-          </a:xfrm>
-          <a:prstGeom prst="rect">
-            <a:avLst/>
-          </a:prstGeom>
-          <a:noFill/>
-          <a:ln/>
-        </p:spPr>
-        <p:txBody>
-          <a:bodyPr wrap="square" lIns="0" tIns="0" rIns="0" bIns="0" rtlCol="0" anchor="ctr"/>
-          <a:lstStyle/>
-          <a:p>
-            <a:pPr indent="0" marL="0">
-              <a:buNone/>
-            </a:pPr>
-            <a:r>
-              <a:rPr lang="en-US" sz="1800" dirty="0">
-                <a:solidFill>
-                  <a:schemeClr val="tx1"/>
-                </a:solidFill>
-              </a:rPr>
-              <a:t>Valor neto preservado por cada 10.000 clientes (valor de los retenidos menos el costo de retenerlos):</a:t>
-            </a:r>
-            <a:endParaRPr lang="en-US" sz="1800" dirty="0"/>
-          </a:p>
-        </p:txBody>
-      </p:sp>
-      <p:sp>
-        <p:nvSpPr>
-          <p:cNvPr id="4" name="imp-0"/>
+          <p:cNvPr id="3" name="seg-0"/>
           <p:cNvSpPr/>
           <p:nvPr/>
         </p:nvSpPr>
         <p:spPr>
           <a:xfrm>
-            <a:off x="548640" y="1965960"/>
-            <a:ext cx="3520440" cy="2606040"/>
+            <a:off x="548640" y="1417320"/>
+            <a:ext cx="3246120" cy="2057400"/>
           </a:xfrm>
           <a:prstGeom prst="roundRect">
             <a:avLst>
-              <a:gd name="adj" fmla="val 4211"/>
+              <a:gd name="adj" fmla="val 5333"/>
             </a:avLst>
           </a:prstGeom>
           <a:solidFill>
-            <a:schemeClr val="bg2"/>
+            <a:schemeClr val="bg1"/>
           </a:solidFill>
           <a:ln/>
           <a:effectLst>
@@ -9839,126 +9803,135 @@
       </p:sp>
       <p:sp>
         <p:nvSpPr>
-          <p:cNvPr id="5" name="imp-c-0"/>
-          <p:cNvSpPr txBox="1"/>
-          <p:nvPr/>
-        </p:nvSpPr>
-        <p:spPr>
-          <a:xfrm>
-            <a:off x="822960" y="2148840"/>
-            <a:ext cx="3017520" cy="411480"/>
-          </a:xfrm>
-          <a:prstGeom prst="rect">
-            <a:avLst/>
-          </a:prstGeom>
-          <a:noFill/>
-          <a:ln/>
-        </p:spPr>
-        <p:txBody>
-          <a:bodyPr wrap="square" lIns="0" tIns="0" rIns="0" bIns="0" rtlCol="0" anchor="ctr"/>
-          <a:lstStyle/>
-          <a:p>
-            <a:pPr indent="0" marL="0">
-              <a:buNone/>
-            </a:pPr>
-            <a:r>
-              <a:rPr lang="en-US" sz="1500" b="1" dirty="0">
-                <a:solidFill>
-                  <a:schemeClr val="tx2"/>
-                </a:solidFill>
-              </a:rPr>
-              <a:t>Costo por retenido: USD 100</a:t>
-            </a:r>
-            <a:endParaRPr lang="en-US" sz="1500" dirty="0"/>
-          </a:p>
-        </p:txBody>
-      </p:sp>
-      <p:sp>
-        <p:nvSpPr>
-          <p:cNvPr id="6" name="imp-v-0"/>
-          <p:cNvSpPr txBox="1"/>
-          <p:nvPr/>
-        </p:nvSpPr>
-        <p:spPr>
-          <a:xfrm>
-            <a:off x="822960" y="2651760"/>
-            <a:ext cx="3017520" cy="822960"/>
-          </a:xfrm>
-          <a:prstGeom prst="rect">
-            <a:avLst/>
-          </a:prstGeom>
-          <a:noFill/>
-          <a:ln/>
-        </p:spPr>
-        <p:txBody>
-          <a:bodyPr wrap="square" lIns="0" tIns="0" rIns="0" bIns="0" rtlCol="0" anchor="ctr"/>
-          <a:lstStyle/>
-          <a:p>
-            <a:pPr indent="0" marL="0">
-              <a:buNone/>
-            </a:pPr>
-            <a:r>
-              <a:rPr lang="en-US" sz="3800" b="1" dirty="0">
-                <a:solidFill>
-                  <a:schemeClr val="accent1"/>
-                </a:solidFill>
-              </a:rPr>
-              <a:t>USD 824 mil</a:t>
-            </a:r>
-            <a:endParaRPr lang="en-US" sz="3800" dirty="0"/>
-          </a:p>
-        </p:txBody>
-      </p:sp>
-      <p:sp>
-        <p:nvSpPr>
-          <p:cNvPr id="7" name="imp-t-0"/>
-          <p:cNvSpPr txBox="1"/>
-          <p:nvPr/>
-        </p:nvSpPr>
-        <p:spPr>
-          <a:xfrm>
-            <a:off x="822960" y="3520440"/>
-            <a:ext cx="3017520" cy="868680"/>
-          </a:xfrm>
-          <a:prstGeom prst="rect">
-            <a:avLst/>
-          </a:prstGeom>
-          <a:noFill/>
-          <a:ln/>
-        </p:spPr>
-        <p:txBody>
-          <a:bodyPr wrap="square" lIns="0" tIns="0" rIns="0" bIns="0" rtlCol="0" anchor="t"/>
-          <a:lstStyle/>
-          <a:p>
-            <a:pPr indent="0" marL="0">
-              <a:buNone/>
-            </a:pPr>
-            <a:r>
-              <a:rPr lang="en-US" sz="1500" dirty="0">
-                <a:solidFill>
-                  <a:schemeClr val="tx1"/>
-                </a:solidFill>
-              </a:rPr>
-              <a:t>priorizando por valor en riesgo (al azar: USD 276 mil)</a:t>
-            </a:r>
-            <a:endParaRPr lang="en-US" sz="1500" dirty="0"/>
-          </a:p>
-        </p:txBody>
-      </p:sp>
-      <p:sp>
-        <p:nvSpPr>
-          <p:cNvPr id="8" name="imp-1"/>
+          <p:cNvPr id="4" name="seg-borde"/>
           <p:cNvSpPr/>
           <p:nvPr/>
         </p:nvSpPr>
         <p:spPr>
           <a:xfrm>
-            <a:off x="4343400" y="1965960"/>
-            <a:ext cx="3520440" cy="2606040"/>
+            <a:off x="548640" y="1417320"/>
+            <a:ext cx="3246120" cy="2057400"/>
           </a:xfrm>
           <a:prstGeom prst="roundRect">
             <a:avLst>
-              <a:gd name="adj" fmla="val 4211"/>
+              <a:gd name="adj" fmla="val 5333"/>
+            </a:avLst>
+          </a:prstGeom>
+          <a:solidFill>
+            <a:schemeClr val="bg1"/>
+          </a:solidFill>
+          <a:ln w="25400">
+            <a:solidFill>
+              <a:schemeClr val="accent2"/>
+            </a:solidFill>
+            <a:prstDash val="solid"/>
+          </a:ln>
+        </p:spPr>
+      </p:sp>
+      <p:sp>
+        <p:nvSpPr>
+          <p:cNvPr id="5" name="seg-t-0"/>
+          <p:cNvSpPr txBox="1"/>
+          <p:nvPr/>
+        </p:nvSpPr>
+        <p:spPr>
+          <a:xfrm>
+            <a:off x="777240" y="1600200"/>
+            <a:ext cx="2788920" cy="1737360"/>
+          </a:xfrm>
+          <a:prstGeom prst="rect">
+            <a:avLst/>
+          </a:prstGeom>
+          <a:noFill/>
+          <a:ln/>
+        </p:spPr>
+        <p:txBody>
+          <a:bodyPr wrap="square" lIns="0" tIns="0" rIns="0" bIns="0" rtlCol="0" anchor="t"/>
+          <a:lstStyle/>
+          <a:p>
+            <a:pPr indent="0" marL="0">
+              <a:spcAft>
+                <a:spcPts val="300"/>
+              </a:spcAft>
+              <a:buNone/>
+            </a:pPr>
+            <a:r>
+              <a:rPr lang="en-US" sz="1800" b="1" dirty="0">
+                <a:solidFill>
+                  <a:schemeClr val="accent2"/>
+                </a:solidFill>
+              </a:rPr>
+              <a:t>Golden</a:t>
+            </a:r>
+            <a:endParaRPr lang="en-US" sz="1800" dirty="0"/>
+          </a:p>
+          <a:p>
+            <a:pPr indent="0" marL="0">
+              <a:spcAft>
+                <a:spcPts val="300"/>
+              </a:spcAft>
+              <a:buNone/>
+            </a:pPr>
+            <a:r>
+              <a:rPr lang="en-US" sz="1300" b="1" dirty="0">
+                <a:solidFill>
+                  <a:schemeClr val="tx2"/>
+                </a:solidFill>
+              </a:rPr>
+              <a:t>Alto valor · alto riesgo</a:t>
+            </a:r>
+            <a:endParaRPr lang="en-US" sz="1800" dirty="0"/>
+          </a:p>
+          <a:p>
+            <a:pPr indent="0" marL="0">
+              <a:spcAft>
+                <a:spcPts val="300"/>
+              </a:spcAft>
+              <a:buNone/>
+            </a:pPr>
+            <a:r>
+              <a:rPr lang="en-US" sz="1300" dirty="0">
+                <a:solidFill>
+                  <a:schemeClr val="tx1"/>
+                </a:solidFill>
+              </a:rPr>
+              <a:t>16 % de la cartera · 70 % abandona · 49 % del valor perdido</a:t>
+            </a:r>
+            <a:endParaRPr lang="en-US" sz="1800" dirty="0"/>
+          </a:p>
+          <a:p>
+            <a:pPr indent="0" marL="0">
+              <a:spcAft>
+                <a:spcPts val="300"/>
+              </a:spcAft>
+              <a:buNone/>
+            </a:pPr>
+            <a:r>
+              <a:rPr lang="en-US" sz="1300" i="1" dirty="0">
+                <a:solidFill>
+                  <a:schemeClr val="tx1"/>
+                </a:solidFill>
+              </a:rPr>
+              <a:t>Rescatar: contacto e incentivo</a:t>
+            </a:r>
+            <a:endParaRPr lang="en-US" sz="1800" dirty="0"/>
+          </a:p>
+        </p:txBody>
+      </p:sp>
+      <p:sp>
+        <p:nvSpPr>
+          <p:cNvPr id="6" name="seg-1"/>
+          <p:cNvSpPr/>
+          <p:nvPr/>
+        </p:nvSpPr>
+        <p:spPr>
+          <a:xfrm>
+            <a:off x="3977640" y="1417320"/>
+            <a:ext cx="3246120" cy="2057400"/>
+          </a:xfrm>
+          <a:prstGeom prst="roundRect">
+            <a:avLst>
+              <a:gd name="adj" fmla="val 5333"/>
             </a:avLst>
           </a:prstGeom>
           <a:solidFill>
@@ -9976,14 +9949,14 @@
       </p:sp>
       <p:sp>
         <p:nvSpPr>
-          <p:cNvPr id="9" name="imp-c-1"/>
+          <p:cNvPr id="7" name="seg-t-1"/>
           <p:cNvSpPr txBox="1"/>
           <p:nvPr/>
         </p:nvSpPr>
         <p:spPr>
           <a:xfrm>
-            <a:off x="4617720" y="2148840"/>
-            <a:ext cx="3017520" cy="411480"/>
+            <a:off x="4206240" y="1600200"/>
+            <a:ext cx="2788920" cy="1737360"/>
           </a:xfrm>
           <a:prstGeom prst="rect">
             <a:avLst/>
@@ -9992,110 +9965,92 @@
           <a:ln/>
         </p:spPr>
         <p:txBody>
-          <a:bodyPr wrap="square" lIns="0" tIns="0" rIns="0" bIns="0" rtlCol="0" anchor="ctr"/>
-          <a:lstStyle/>
-          <a:p>
-            <a:pPr indent="0" marL="0">
-              <a:buNone/>
-            </a:pPr>
-            <a:r>
-              <a:rPr lang="en-US" sz="1500" b="1" dirty="0">
+          <a:bodyPr wrap="square" lIns="0" tIns="0" rIns="0" bIns="0" rtlCol="0" anchor="t"/>
+          <a:lstStyle/>
+          <a:p>
+            <a:pPr indent="0" marL="0">
+              <a:spcAft>
+                <a:spcPts val="300"/>
+              </a:spcAft>
+              <a:buNone/>
+            </a:pPr>
+            <a:r>
+              <a:rPr lang="en-US" sz="1800" b="1" dirty="0">
+                <a:solidFill>
+                  <a:schemeClr val="accent1"/>
+                </a:solidFill>
+              </a:rPr>
+              <a:t>Champions</a:t>
+            </a:r>
+            <a:endParaRPr lang="en-US" sz="1800" dirty="0"/>
+          </a:p>
+          <a:p>
+            <a:pPr indent="0" marL="0">
+              <a:spcAft>
+                <a:spcPts val="300"/>
+              </a:spcAft>
+              <a:buNone/>
+            </a:pPr>
+            <a:r>
+              <a:rPr lang="en-US" sz="1300" b="1" dirty="0">
                 <a:solidFill>
                   <a:schemeClr val="tx2"/>
                 </a:solidFill>
               </a:rPr>
-              <a:t>Costo por retenido: USD 1.000</a:t>
-            </a:r>
-            <a:endParaRPr lang="en-US" sz="1500" dirty="0"/>
-          </a:p>
-        </p:txBody>
-      </p:sp>
-      <p:sp>
-        <p:nvSpPr>
-          <p:cNvPr id="10" name="imp-v-1"/>
-          <p:cNvSpPr txBox="1"/>
-          <p:nvPr/>
-        </p:nvSpPr>
-        <p:spPr>
-          <a:xfrm>
-            <a:off x="4617720" y="2651760"/>
-            <a:ext cx="3017520" cy="822960"/>
-          </a:xfrm>
-          <a:prstGeom prst="rect">
-            <a:avLst/>
-          </a:prstGeom>
-          <a:noFill/>
-          <a:ln/>
-        </p:spPr>
-        <p:txBody>
-          <a:bodyPr wrap="square" lIns="0" tIns="0" rIns="0" bIns="0" rtlCol="0" anchor="ctr"/>
-          <a:lstStyle/>
-          <a:p>
-            <a:pPr indent="0" marL="0">
-              <a:buNone/>
-            </a:pPr>
-            <a:r>
-              <a:rPr lang="en-US" sz="3800" b="1" dirty="0">
-                <a:solidFill>
-                  <a:schemeClr val="accent1"/>
-                </a:solidFill>
-              </a:rPr>
-              <a:t>USD 455 mil</a:t>
-            </a:r>
-            <a:endParaRPr lang="en-US" sz="3800" dirty="0"/>
-          </a:p>
-        </p:txBody>
-      </p:sp>
-      <p:sp>
-        <p:nvSpPr>
-          <p:cNvPr id="11" name="imp-t-1"/>
-          <p:cNvSpPr txBox="1"/>
-          <p:nvPr/>
-        </p:nvSpPr>
-        <p:spPr>
-          <a:xfrm>
-            <a:off x="4617720" y="3520440"/>
-            <a:ext cx="3017520" cy="868680"/>
-          </a:xfrm>
-          <a:prstGeom prst="rect">
-            <a:avLst/>
-          </a:prstGeom>
-          <a:noFill/>
-          <a:ln/>
-        </p:spPr>
-        <p:txBody>
-          <a:bodyPr wrap="square" lIns="0" tIns="0" rIns="0" bIns="0" rtlCol="0" anchor="t"/>
-          <a:lstStyle/>
-          <a:p>
-            <a:pPr indent="0" marL="0">
-              <a:buNone/>
-            </a:pPr>
-            <a:r>
-              <a:rPr lang="en-US" sz="1500" dirty="0">
+              <a:t>Alto valor · bajo riesgo</a:t>
+            </a:r>
+            <a:endParaRPr lang="en-US" sz="1800" dirty="0"/>
+          </a:p>
+          <a:p>
+            <a:pPr indent="0" marL="0">
+              <a:spcAft>
+                <a:spcPts val="300"/>
+              </a:spcAft>
+              <a:buNone/>
+            </a:pPr>
+            <a:r>
+              <a:rPr lang="en-US" sz="1300" dirty="0">
                 <a:solidFill>
                   <a:schemeClr val="tx1"/>
                 </a:solidFill>
               </a:rPr>
-              <a:t>priorizando por valor en riesgo (al azar: USD 190 mil)</a:t>
-            </a:r>
-            <a:endParaRPr lang="en-US" sz="1500" dirty="0"/>
-          </a:p>
-        </p:txBody>
-      </p:sp>
-      <p:sp>
-        <p:nvSpPr>
-          <p:cNvPr id="12" name="imp-2"/>
+              <a:t>34 % de la cartera · 18 % abandona</a:t>
+            </a:r>
+            <a:endParaRPr lang="en-US" sz="1800" dirty="0"/>
+          </a:p>
+          <a:p>
+            <a:pPr indent="0" marL="0">
+              <a:spcAft>
+                <a:spcPts val="300"/>
+              </a:spcAft>
+              <a:buNone/>
+            </a:pPr>
+            <a:r>
+              <a:rPr lang="en-US" sz="1300" i="1" dirty="0">
+                <a:solidFill>
+                  <a:schemeClr val="tx1"/>
+                </a:solidFill>
+              </a:rPr>
+              <a:t>Fidelizar sin descuento</a:t>
+            </a:r>
+            <a:endParaRPr lang="en-US" sz="1800" dirty="0"/>
+          </a:p>
+        </p:txBody>
+      </p:sp>
+      <p:sp>
+        <p:nvSpPr>
+          <p:cNvPr id="8" name="seg-2"/>
           <p:cNvSpPr/>
           <p:nvPr/>
         </p:nvSpPr>
         <p:spPr>
           <a:xfrm>
-            <a:off x="8138160" y="1965960"/>
-            <a:ext cx="3520440" cy="2606040"/>
+            <a:off x="548640" y="3657600"/>
+            <a:ext cx="3246120" cy="2057400"/>
           </a:xfrm>
           <a:prstGeom prst="roundRect">
             <a:avLst>
-              <a:gd name="adj" fmla="val 4211"/>
+              <a:gd name="adj" fmla="val 5333"/>
             </a:avLst>
           </a:prstGeom>
           <a:solidFill>
@@ -10113,14 +10068,14 @@
       </p:sp>
       <p:sp>
         <p:nvSpPr>
-          <p:cNvPr id="13" name="imp-c-2"/>
+          <p:cNvPr id="9" name="seg-t-2"/>
           <p:cNvSpPr txBox="1"/>
           <p:nvPr/>
         </p:nvSpPr>
         <p:spPr>
           <a:xfrm>
-            <a:off x="8412480" y="2148840"/>
-            <a:ext cx="3017520" cy="411480"/>
+            <a:off x="777240" y="3840480"/>
+            <a:ext cx="2788920" cy="1737360"/>
           </a:xfrm>
           <a:prstGeom prst="rect">
             <a:avLst/>
@@ -10129,6 +10084,351 @@
           <a:ln/>
         </p:spPr>
         <p:txBody>
+          <a:bodyPr wrap="square" lIns="0" tIns="0" rIns="0" bIns="0" rtlCol="0" anchor="t"/>
+          <a:lstStyle/>
+          <a:p>
+            <a:pPr indent="0" marL="0">
+              <a:spcAft>
+                <a:spcPts val="300"/>
+              </a:spcAft>
+              <a:buNone/>
+            </a:pPr>
+            <a:r>
+              <a:rPr lang="en-US" sz="1800" b="1" dirty="0">
+                <a:solidFill>
+                  <a:schemeClr val="accent6"/>
+                </a:solidFill>
+              </a:rPr>
+              <a:t>En riesgo de bajo valor</a:t>
+            </a:r>
+            <a:endParaRPr lang="en-US" sz="1800" dirty="0"/>
+          </a:p>
+          <a:p>
+            <a:pPr indent="0" marL="0">
+              <a:spcAft>
+                <a:spcPts val="300"/>
+              </a:spcAft>
+              <a:buNone/>
+            </a:pPr>
+            <a:r>
+              <a:rPr lang="en-US" sz="1300" b="1" dirty="0">
+                <a:solidFill>
+                  <a:schemeClr val="tx2"/>
+                </a:solidFill>
+              </a:rPr>
+              <a:t>Bajo valor · alto riesgo</a:t>
+            </a:r>
+            <a:endParaRPr lang="en-US" sz="1800" dirty="0"/>
+          </a:p>
+          <a:p>
+            <a:pPr indent="0" marL="0">
+              <a:spcAft>
+                <a:spcPts val="300"/>
+              </a:spcAft>
+              <a:buNone/>
+            </a:pPr>
+            <a:r>
+              <a:rPr lang="en-US" sz="1300" dirty="0">
+                <a:solidFill>
+                  <a:schemeClr val="tx1"/>
+                </a:solidFill>
+              </a:rPr>
+              <a:t>4 % de la cartera · 73 % abandona</a:t>
+            </a:r>
+            <a:endParaRPr lang="en-US" sz="1800" dirty="0"/>
+          </a:p>
+          <a:p>
+            <a:pPr indent="0" marL="0">
+              <a:spcAft>
+                <a:spcPts val="300"/>
+              </a:spcAft>
+              <a:buNone/>
+            </a:pPr>
+            <a:r>
+              <a:rPr lang="en-US" sz="1300" i="1" dirty="0">
+                <a:solidFill>
+                  <a:schemeClr val="tx1"/>
+                </a:solidFill>
+              </a:rPr>
+              <a:t>Solo acciones de bajo costo</a:t>
+            </a:r>
+            <a:endParaRPr lang="en-US" sz="1800" dirty="0"/>
+          </a:p>
+        </p:txBody>
+      </p:sp>
+      <p:sp>
+        <p:nvSpPr>
+          <p:cNvPr id="10" name="seg-3"/>
+          <p:cNvSpPr/>
+          <p:nvPr/>
+        </p:nvSpPr>
+        <p:spPr>
+          <a:xfrm>
+            <a:off x="3977640" y="3657600"/>
+            <a:ext cx="3246120" cy="2057400"/>
+          </a:xfrm>
+          <a:prstGeom prst="roundRect">
+            <a:avLst>
+              <a:gd name="adj" fmla="val 5333"/>
+            </a:avLst>
+          </a:prstGeom>
+          <a:solidFill>
+            <a:schemeClr val="bg2"/>
+          </a:solidFill>
+          <a:ln/>
+          <a:effectLst>
+            <a:outerShdw sx="100000" sy="100000" kx="0" ky="0" algn="bl" rotWithShape="0" blurRad="76200" dist="25400" dir="5400000">
+              <a:srgbClr val="000000">
+                <a:alpha val="12000"/>
+              </a:srgbClr>
+            </a:outerShdw>
+          </a:effectLst>
+        </p:spPr>
+      </p:sp>
+      <p:sp>
+        <p:nvSpPr>
+          <p:cNvPr id="11" name="seg-t-3"/>
+          <p:cNvSpPr txBox="1"/>
+          <p:nvPr/>
+        </p:nvSpPr>
+        <p:spPr>
+          <a:xfrm>
+            <a:off x="4206240" y="3840480"/>
+            <a:ext cx="2788920" cy="1737360"/>
+          </a:xfrm>
+          <a:prstGeom prst="rect">
+            <a:avLst/>
+          </a:prstGeom>
+          <a:noFill/>
+          <a:ln/>
+        </p:spPr>
+        <p:txBody>
+          <a:bodyPr wrap="square" lIns="0" tIns="0" rIns="0" bIns="0" rtlCol="0" anchor="t"/>
+          <a:lstStyle/>
+          <a:p>
+            <a:pPr indent="0" marL="0">
+              <a:spcAft>
+                <a:spcPts val="300"/>
+              </a:spcAft>
+              <a:buNone/>
+            </a:pPr>
+            <a:r>
+              <a:rPr lang="en-US" sz="1800" b="1" dirty="0">
+                <a:solidFill>
+                  <a:schemeClr val="accent4"/>
+                </a:solidFill>
+              </a:rPr>
+              <a:t>Estables de bajo valor</a:t>
+            </a:r>
+            <a:endParaRPr lang="en-US" sz="1800" dirty="0"/>
+          </a:p>
+          <a:p>
+            <a:pPr indent="0" marL="0">
+              <a:spcAft>
+                <a:spcPts val="300"/>
+              </a:spcAft>
+              <a:buNone/>
+            </a:pPr>
+            <a:r>
+              <a:rPr lang="en-US" sz="1300" b="1" dirty="0">
+                <a:solidFill>
+                  <a:schemeClr val="tx2"/>
+                </a:solidFill>
+              </a:rPr>
+              <a:t>Bajo valor · bajo riesgo</a:t>
+            </a:r>
+            <a:endParaRPr lang="en-US" sz="1800" dirty="0"/>
+          </a:p>
+          <a:p>
+            <a:pPr indent="0" marL="0">
+              <a:spcAft>
+                <a:spcPts val="300"/>
+              </a:spcAft>
+              <a:buNone/>
+            </a:pPr>
+            <a:r>
+              <a:rPr lang="en-US" sz="1300" dirty="0">
+                <a:solidFill>
+                  <a:schemeClr val="tx1"/>
+                </a:solidFill>
+              </a:rPr>
+              <a:t>46 % de la cartera · 14 % abandona</a:t>
+            </a:r>
+            <a:endParaRPr lang="en-US" sz="1800" dirty="0"/>
+          </a:p>
+          <a:p>
+            <a:pPr indent="0" marL="0">
+              <a:spcAft>
+                <a:spcPts val="300"/>
+              </a:spcAft>
+              <a:buNone/>
+            </a:pPr>
+            <a:r>
+              <a:rPr lang="en-US" sz="1300" i="1" dirty="0">
+                <a:solidFill>
+                  <a:schemeClr val="tx1"/>
+                </a:solidFill>
+              </a:rPr>
+              <a:t>Sin acción</a:t>
+            </a:r>
+            <a:endParaRPr lang="en-US" sz="1800" dirty="0"/>
+          </a:p>
+        </p:txBody>
+      </p:sp>
+      <p:sp>
+        <p:nvSpPr>
+          <p:cNvPr id="12" name="cac"/>
+          <p:cNvSpPr/>
+          <p:nvPr/>
+        </p:nvSpPr>
+        <p:spPr>
+          <a:xfrm>
+            <a:off x="7589520" y="1417320"/>
+            <a:ext cx="4023360" cy="4297680"/>
+          </a:xfrm>
+          <a:prstGeom prst="roundRect">
+            <a:avLst>
+              <a:gd name="adj" fmla="val 2727"/>
+            </a:avLst>
+          </a:prstGeom>
+          <a:solidFill>
+            <a:schemeClr val="tx2"/>
+          </a:solidFill>
+          <a:ln/>
+          <a:effectLst>
+            <a:outerShdw sx="100000" sy="100000" kx="0" ky="0" algn="bl" rotWithShape="0" blurRad="76200" dist="25400" dir="5400000">
+              <a:srgbClr val="000000">
+                <a:alpha val="12000"/>
+              </a:srgbClr>
+            </a:outerShdw>
+          </a:effectLst>
+        </p:spPr>
+      </p:sp>
+      <p:sp>
+        <p:nvSpPr>
+          <p:cNvPr id="13" name="cac-t"/>
+          <p:cNvSpPr txBox="1"/>
+          <p:nvPr/>
+        </p:nvSpPr>
+        <p:spPr>
+          <a:xfrm>
+            <a:off x="7863840" y="1645920"/>
+            <a:ext cx="3474720" cy="3931920"/>
+          </a:xfrm>
+          <a:prstGeom prst="rect">
+            <a:avLst/>
+          </a:prstGeom>
+          <a:noFill/>
+          <a:ln/>
+        </p:spPr>
+        <p:txBody>
+          <a:bodyPr wrap="square" lIns="0" tIns="0" rIns="0" bIns="0" rtlCol="0" anchor="t"/>
+          <a:lstStyle/>
+          <a:p>
+            <a:pPr indent="0" marL="0">
+              <a:spcAft>
+                <a:spcPts val="400"/>
+              </a:spcAft>
+              <a:buNone/>
+            </a:pPr>
+            <a:r>
+              <a:rPr lang="en-US" sz="1500" b="1" dirty="0">
+                <a:solidFill>
+                  <a:schemeClr val="accent3"/>
+                </a:solidFill>
+              </a:rPr>
+              <a:t>Retener un Golden conviene si cuesta menos de</a:t>
+            </a:r>
+            <a:endParaRPr lang="en-US" sz="1500" dirty="0"/>
+          </a:p>
+          <a:p>
+            <a:pPr indent="0" marL="0">
+              <a:spcAft>
+                <a:spcPts val="400"/>
+              </a:spcAft>
+              <a:buNone/>
+            </a:pPr>
+            <a:r>
+              <a:rPr lang="en-US" sz="4800" b="1" dirty="0">
+                <a:solidFill>
+                  <a:schemeClr val="bg1"/>
+                </a:solidFill>
+              </a:rPr>
+              <a:t>USD 854</a:t>
+            </a:r>
+            <a:endParaRPr lang="en-US" sz="1500" dirty="0"/>
+          </a:p>
+          <a:p>
+            <a:pPr indent="0" marL="0">
+              <a:spcAft>
+                <a:spcPts val="400"/>
+              </a:spcAft>
+              <a:buNone/>
+            </a:pPr>
+            <a:r>
+              <a:rPr lang="en-US" sz="1400" dirty="0">
+                <a:solidFill>
+                  <a:schemeClr val="bg1"/>
+                </a:solidFill>
+              </a:rPr>
+              <a:t>Conseguir un cliente nuevo (CAC genérico): USD 300. Un Golden vale USD 2.135; un cliente nuevo promedio, USD 1.581.</a:t>
+            </a:r>
+            <a:endParaRPr lang="en-US" sz="1500" dirty="0"/>
+          </a:p>
+          <a:p>
+            <a:pPr indent="0" marL="0">
+              <a:spcAft>
+                <a:spcPts val="400"/>
+              </a:spcAft>
+              <a:buNone/>
+            </a:pPr>
+            <a:r>
+              <a:rPr lang="en-US" sz="600" dirty="0">
+                <a:solidFill>
+                  <a:srgbClr val="000000"/>
+                </a:solidFill>
+              </a:rPr>
+              <a:t> </a:t>
+            </a:r>
+            <a:endParaRPr lang="en-US" sz="1500" dirty="0"/>
+          </a:p>
+          <a:p>
+            <a:pPr indent="0" marL="0">
+              <a:spcAft>
+                <a:spcPts val="400"/>
+              </a:spcAft>
+              <a:buNone/>
+            </a:pPr>
+            <a:r>
+              <a:rPr lang="en-US" sz="1400" dirty="0">
+                <a:solidFill>
+                  <a:schemeClr val="bg1"/>
+                </a:solidFill>
+              </a:rPr>
+              <a:t>Con USD 100 por retenido: +USD 255 mil por cada 10.000 clientes frente a reemplazarlos. Con USD 1.000 ya no conviene.</a:t>
+            </a:r>
+            <a:endParaRPr lang="en-US" sz="1500" dirty="0"/>
+          </a:p>
+        </p:txBody>
+      </p:sp>
+      <p:sp>
+        <p:nvSpPr>
+          <p:cNvPr id="14" name="imp-sup"/>
+          <p:cNvSpPr txBox="1"/>
+          <p:nvPr/>
+        </p:nvSpPr>
+        <p:spPr>
+          <a:xfrm>
+            <a:off x="548640" y="5897880"/>
+            <a:ext cx="11064240" cy="365760"/>
+          </a:xfrm>
+          <a:prstGeom prst="rect">
+            <a:avLst/>
+          </a:prstGeom>
+          <a:noFill/>
+          <a:ln/>
+        </p:spPr>
+        <p:txBody>
           <a:bodyPr wrap="square" lIns="0" tIns="0" rIns="0" bIns="0" rtlCol="0" anchor="ctr"/>
           <a:lstStyle/>
           <a:p>
@@ -10136,169 +10436,14 @@
               <a:buNone/>
             </a:pPr>
             <a:r>
-              <a:rPr lang="en-US" sz="1500" b="1" dirty="0">
-                <a:solidFill>
-                  <a:schemeClr val="tx2"/>
-                </a:solidFill>
-              </a:rPr>
-              <a:t>Costo por retenido: USD 10.000</a:t>
-            </a:r>
-            <a:endParaRPr lang="en-US" sz="1500" dirty="0"/>
-          </a:p>
-        </p:txBody>
-      </p:sp>
-      <p:sp>
-        <p:nvSpPr>
-          <p:cNvPr id="14" name="imp-v-2"/>
-          <p:cNvSpPr txBox="1"/>
-          <p:nvPr/>
-        </p:nvSpPr>
-        <p:spPr>
-          <a:xfrm>
-            <a:off x="8412480" y="2651760"/>
-            <a:ext cx="3017520" cy="822960"/>
-          </a:xfrm>
-          <a:prstGeom prst="rect">
-            <a:avLst/>
-          </a:prstGeom>
-          <a:noFill/>
-          <a:ln/>
-        </p:spPr>
-        <p:txBody>
-          <a:bodyPr wrap="square" lIns="0" tIns="0" rIns="0" bIns="0" rtlCol="0" anchor="ctr"/>
-          <a:lstStyle/>
-          <a:p>
-            <a:pPr indent="0" marL="0">
-              <a:buNone/>
-            </a:pPr>
-            <a:r>
-              <a:rPr lang="en-US" sz="3800" b="1" dirty="0">
-                <a:solidFill>
-                  <a:schemeClr val="accent2"/>
-                </a:solidFill>
-              </a:rPr>
-              <a:t>No conviene</a:t>
-            </a:r>
-            <a:endParaRPr lang="en-US" sz="3800" dirty="0"/>
-          </a:p>
-        </p:txBody>
-      </p:sp>
-      <p:sp>
-        <p:nvSpPr>
-          <p:cNvPr id="15" name="imp-t-2"/>
-          <p:cNvSpPr txBox="1"/>
-          <p:nvPr/>
-        </p:nvSpPr>
-        <p:spPr>
-          <a:xfrm>
-            <a:off x="8412480" y="3520440"/>
-            <a:ext cx="3017520" cy="868680"/>
-          </a:xfrm>
-          <a:prstGeom prst="rect">
-            <a:avLst/>
-          </a:prstGeom>
-          <a:noFill/>
-          <a:ln/>
-        </p:spPr>
-        <p:txBody>
-          <a:bodyPr wrap="square" lIns="0" tIns="0" rIns="0" bIns="0" rtlCol="0" anchor="t"/>
-          <a:lstStyle/>
-          <a:p>
-            <a:pPr indent="0" marL="0">
-              <a:buNone/>
-            </a:pPr>
-            <a:r>
-              <a:rPr lang="en-US" sz="1500" dirty="0">
-                <a:solidFill>
-                  <a:schemeClr val="tx1"/>
-                </a:solidFill>
-              </a:rPr>
-              <a:t>ningún cliente vale tanto: conviene invertir en clientes nuevos</a:t>
-            </a:r>
-            <a:endParaRPr lang="en-US" sz="1500" dirty="0"/>
-          </a:p>
-        </p:txBody>
-      </p:sp>
-      <p:sp>
-        <p:nvSpPr>
-          <p:cNvPr id="16" name="imp-supuestos"/>
-          <p:cNvSpPr txBox="1"/>
-          <p:nvPr/>
-        </p:nvSpPr>
-        <p:spPr>
-          <a:xfrm>
-            <a:off x="548640" y="4846320"/>
-            <a:ext cx="11064240" cy="731520"/>
-          </a:xfrm>
-          <a:prstGeom prst="rect">
-            <a:avLst/>
-          </a:prstGeom>
-          <a:noFill/>
-          <a:ln/>
-        </p:spPr>
-        <p:txBody>
-          <a:bodyPr wrap="square" lIns="0" tIns="0" rIns="0" bIns="0" rtlCol="0" anchor="ctr"/>
-          <a:lstStyle/>
-          <a:p>
-            <a:pPr indent="0" marL="0">
-              <a:buNone/>
-            </a:pPr>
-            <a:r>
-              <a:rPr lang="en-US" sz="1600" b="1" dirty="0">
-                <a:solidFill>
-                  <a:schemeClr val="tx1"/>
-                </a:solidFill>
-              </a:rPr>
-              <a:t>Supuestos genéricos: </a:t>
-            </a:r>
-            <a:pPr indent="0" marL="0">
-              <a:buNone/>
-            </a:pPr>
-            <a:r>
-              <a:rPr lang="en-US" sz="1600" dirty="0">
-                <a:solidFill>
-                  <a:schemeClr val="tx1"/>
-                </a:solidFill>
-              </a:rPr>
-              <a:t>valor del cliente = cargo mensual × 24 meses; se retiene al 30 % de los contactados que iban a irse; solo se contacta a quien vale más que su costo de retención.</a:t>
-            </a:r>
-            <a:endParaRPr lang="en-US" sz="1600" dirty="0"/>
-          </a:p>
-        </p:txBody>
-      </p:sp>
-      <p:sp>
-        <p:nvSpPr>
-          <p:cNvPr id="17" name="imp-auto"/>
-          <p:cNvSpPr txBox="1"/>
-          <p:nvPr/>
-        </p:nvSpPr>
-        <p:spPr>
-          <a:xfrm>
-            <a:off x="548640" y="5623560"/>
-            <a:ext cx="11064240" cy="548640"/>
-          </a:xfrm>
-          <a:prstGeom prst="rect">
-            <a:avLst/>
-          </a:prstGeom>
-          <a:noFill/>
-          <a:ln/>
-        </p:spPr>
-        <p:txBody>
-          <a:bodyPr wrap="square" lIns="0" tIns="0" rIns="0" bIns="0" rtlCol="0" anchor="ctr"/>
-          <a:lstStyle/>
-          <a:p>
-            <a:pPr indent="0" marL="0">
-              <a:buNone/>
-            </a:pPr>
-            <a:r>
-              <a:rPr lang="en-US" sz="1600" b="1" dirty="0">
-                <a:solidFill>
-                  <a:schemeClr val="tx2"/>
-                </a:solidFill>
-              </a:rPr>
-              <a:t>Priorizar por valor en riesgo (probabilidad × valor) rescata a los que se van y además gastan mucho.</a:t>
-            </a:r>
-            <a:endParaRPr lang="en-US" sz="1600" dirty="0"/>
+              <a:rPr lang="en-US" sz="1300" dirty="0">
+                <a:solidFill>
+                  <a:schemeClr val="accent4"/>
+                </a:solidFill>
+              </a:rPr>
+              <a:t>Supuestos genéricos: valor = cargo mensual × 24 meses de ciclo de vida; la acción retiene al 30 % de los Golden que iban a irse.</a:t>
+            </a:r>
+            <a:endParaRPr lang="en-US" sz="1300" dirty="0"/>
           </a:p>
         </p:txBody>
       </p:sp>

</xml_diff>

<commit_message>
Revisión final: decimales con coma en los gráficos, definición de valor alto y base del valor promedio
</commit_message>
<xml_diff>
--- a/docs/Presentacion_Final_Proyecto_Integrador.pptx
+++ b/docs/Presentacion_Final_Proyecto_Integrador.pptx
@@ -335,7 +335,7 @@
                 <a:latin typeface="+mn-lt"/>
               </a:defRPr>
             </a:pPr>
-            <a:endParaRPr lang="en-US"/>
+            <a:endParaRPr lang="es-AR"/>
           </a:p>
         </c:txPr>
         <c:crossAx val="2094734552"/>
@@ -387,7 +387,7 @@
                 <a:latin typeface="+mn-lt"/>
               </a:defRPr>
             </a:pPr>
-            <a:endParaRPr lang="en-US"/>
+            <a:endParaRPr lang="es-AR"/>
           </a:p>
         </c:txPr>
         <c:crossAx val="2094734554"/>
@@ -669,7 +669,7 @@
                 <a:latin typeface="+mn-lt"/>
               </a:defRPr>
             </a:pPr>
-            <a:endParaRPr lang="en-US"/>
+            <a:endParaRPr lang="es-AR"/>
           </a:p>
         </c:txPr>
         <c:crossAx val="2094734552"/>
@@ -721,7 +721,7 @@
                 <a:latin typeface="+mn-lt"/>
               </a:defRPr>
             </a:pPr>
-            <a:endParaRPr lang="en-US"/>
+            <a:endParaRPr lang="es-AR"/>
           </a:p>
         </c:txPr>
         <c:crossAx val="2094734554"/>
@@ -1020,7 +1020,7 @@
                 <a:latin typeface="+mn-lt"/>
               </a:defRPr>
             </a:pPr>
-            <a:endParaRPr lang="en-US"/>
+            <a:endParaRPr lang="es-AR"/>
           </a:p>
         </c:txPr>
         <c:crossAx val="2094734552"/>
@@ -1072,7 +1072,7 @@
                 <a:latin typeface="+mn-lt"/>
               </a:defRPr>
             </a:pPr>
-            <a:endParaRPr lang="en-US"/>
+            <a:endParaRPr lang="es-AR"/>
           </a:p>
         </c:txPr>
         <c:crossAx val="2094734554"/>
@@ -1542,7 +1542,7 @@
                 <a:latin typeface="+mn-lt"/>
               </a:defRPr>
             </a:pPr>
-            <a:endParaRPr lang="en-US"/>
+            <a:endParaRPr lang="es-AR"/>
           </a:p>
         </c:txPr>
         <c:crossAx val="2094734552"/>
@@ -1594,7 +1594,7 @@
                 <a:latin typeface="+mn-lt"/>
               </a:defRPr>
             </a:pPr>
-            <a:endParaRPr lang="en-US"/>
+            <a:endParaRPr lang="es-AR"/>
           </a:p>
         </c:txPr>
         <c:crossAx val="2094734554"/>
@@ -1860,7 +1860,7 @@
                 <a:latin typeface="+mn-lt"/>
               </a:defRPr>
             </a:pPr>
-            <a:endParaRPr lang="en-US"/>
+            <a:endParaRPr lang="es-AR"/>
           </a:p>
         </c:txPr>
         <c:crossAx val="2094734552"/>
@@ -1899,7 +1899,7 @@
                 <a:latin typeface="+mn-lt"/>
               </a:defRPr>
             </a:pPr>
-            <a:endParaRPr lang="en-US"/>
+            <a:endParaRPr lang="es-AR"/>
           </a:p>
         </c:txPr>
         <c:crossAx val="2094734554"/>

</xml_diff>

<commit_message>
Ecuación explícita de retener contra adquirir (costo máximo = valor Golden − valor nuevo + CAC) y costo del proyecto en orden de magnitud
</commit_message>
<xml_diff>
--- a/docs/Presentacion_Final_Proyecto_Integrador.pptx
+++ b/docs/Presentacion_Final_Proyecto_Integrador.pptx
@@ -5587,11 +5587,11 @@
         <p:spPr>
           <a:xfrm>
             <a:off x="548640" y="1645920"/>
-            <a:ext cx="3520440" cy="2468880"/>
+            <a:ext cx="3520440" cy="2240280"/>
           </a:xfrm>
           <a:prstGeom prst="roundRect">
             <a:avLst>
-              <a:gd name="adj" fmla="val 4444"/>
+              <a:gd name="adj" fmla="val 4898"/>
             </a:avLst>
           </a:prstGeom>
           <a:solidFill>
@@ -5721,11 +5721,11 @@
         <p:spPr>
           <a:xfrm>
             <a:off x="4343400" y="1645920"/>
-            <a:ext cx="3520440" cy="2468880"/>
+            <a:ext cx="3520440" cy="2240280"/>
           </a:xfrm>
           <a:prstGeom prst="roundRect">
             <a:avLst>
-              <a:gd name="adj" fmla="val 4444"/>
+              <a:gd name="adj" fmla="val 4898"/>
             </a:avLst>
           </a:prstGeom>
           <a:solidFill>
@@ -5855,11 +5855,11 @@
         <p:spPr>
           <a:xfrm>
             <a:off x="8138160" y="1645920"/>
-            <a:ext cx="3520440" cy="2468880"/>
+            <a:ext cx="3520440" cy="2240280"/>
           </a:xfrm>
           <a:prstGeom prst="roundRect">
             <a:avLst>
-              <a:gd name="adj" fmla="val 4444"/>
+              <a:gd name="adj" fmla="val 4898"/>
             </a:avLst>
           </a:prstGeom>
           <a:solidFill>
@@ -5982,14 +5982,61 @@
       </p:sp>
       <p:sp>
         <p:nvSpPr>
-          <p:cNvPr id="15" name="links"/>
+          <p:cNvPr id="15" name="costo-proy"/>
           <p:cNvSpPr txBox="1"/>
           <p:nvPr/>
         </p:nvSpPr>
         <p:spPr>
           <a:xfrm>
-            <a:off x="548640" y="4572000"/>
-            <a:ext cx="11064240" cy="914400"/>
+            <a:off x="548640" y="4206240"/>
+            <a:ext cx="11064240" cy="640080"/>
+          </a:xfrm>
+          <a:prstGeom prst="rect">
+            <a:avLst/>
+          </a:prstGeom>
+          <a:noFill/>
+          <a:ln/>
+        </p:spPr>
+        <p:txBody>
+          <a:bodyPr wrap="square" lIns="0" tIns="0" rIns="0" bIns="0" rtlCol="0" anchor="t"/>
+          <a:lstStyle/>
+          <a:p>
+            <a:pPr indent="0" marL="0">
+              <a:buNone/>
+            </a:pPr>
+            <a:r>
+              <a:rPr lang="en-US" sz="1600" b="1" dirty="0">
+                <a:solidFill>
+                  <a:schemeClr val="accent3"/>
+                </a:solidFill>
+              </a:rPr>
+              <a:t>Costo del proyecto: </a:t>
+            </a:r>
+            <a:pPr indent="0" marL="0">
+              <a:buNone/>
+            </a:pPr>
+            <a:r>
+              <a:rPr lang="en-US" sz="1600" dirty="0">
+                <a:solidFill>
+                  <a:schemeClr val="bg1"/>
+                </a:solidFill>
+              </a:rPr>
+              <a:t>2 meses con un analista y un desarrollador a media jornada ≈ USD 5.600; primer año ≈ USD 8.600. Se recupera reteniendo 8 Golden.</a:t>
+            </a:r>
+            <a:endParaRPr lang="en-US" sz="1600" dirty="0"/>
+          </a:p>
+        </p:txBody>
+      </p:sp>
+      <p:sp>
+        <p:nvSpPr>
+          <p:cNvPr id="16" name="links"/>
+          <p:cNvSpPr txBox="1"/>
+          <p:nvPr/>
+        </p:nvSpPr>
+        <p:spPr>
+          <a:xfrm>
+            <a:off x="548640" y="4892040"/>
+            <a:ext cx="11064240" cy="777240"/>
           </a:xfrm>
           <a:prstGeom prst="rect">
             <a:avLst/>
@@ -6080,7 +6127,7 @@
       </p:sp>
       <p:sp>
         <p:nvSpPr>
-          <p:cNvPr id="16" name="gracias"/>
+          <p:cNvPr id="17" name="gracias"/>
           <p:cNvSpPr txBox="1"/>
           <p:nvPr/>
         </p:nvSpPr>
@@ -10366,12 +10413,29 @@
               <a:buNone/>
             </a:pPr>
             <a:r>
+              <a:rPr lang="en-US" sz="1400" b="1" dirty="0">
+                <a:solidFill>
+                  <a:schemeClr val="bg1"/>
+                </a:solidFill>
+              </a:rPr>
+              <a:t>Costo de retener &lt; valor Golden − valor nuevo + CAC</a:t>
+            </a:r>
+            <a:endParaRPr lang="en-US" sz="1500" dirty="0"/>
+          </a:p>
+          <a:p>
+            <a:pPr indent="0" marL="0">
+              <a:spcAft>
+                <a:spcPts val="400"/>
+              </a:spcAft>
+              <a:buNone/>
+            </a:pPr>
+            <a:r>
               <a:rPr lang="en-US" sz="1400" dirty="0">
                 <a:solidFill>
                   <a:schemeClr val="bg1"/>
                 </a:solidFill>
               </a:rPr>
-              <a:t>Conseguir un cliente nuevo (CAC genérico): USD 300. Un Golden vale USD 2.135; un cliente nuevo promedio, USD 1.581.</a:t>
+              <a:t>= 2.135 − 1.581 + 300 (CAC genérico) = 2,8 veces el CAC</a:t>
             </a:r>
             <a:endParaRPr lang="en-US" sz="1500" dirty="0"/>
           </a:p>

</xml_diff>

<commit_message>
Vuelve a la versión anterior: sin la ecuación ampliada ni el costo del proyecto
</commit_message>
<xml_diff>
--- a/docs/Presentacion_Final_Proyecto_Integrador.pptx
+++ b/docs/Presentacion_Final_Proyecto_Integrador.pptx
@@ -5587,11 +5587,11 @@
         <p:spPr>
           <a:xfrm>
             <a:off x="548640" y="1645920"/>
-            <a:ext cx="3520440" cy="2240280"/>
+            <a:ext cx="3520440" cy="2468880"/>
           </a:xfrm>
           <a:prstGeom prst="roundRect">
             <a:avLst>
-              <a:gd name="adj" fmla="val 4898"/>
+              <a:gd name="adj" fmla="val 4444"/>
             </a:avLst>
           </a:prstGeom>
           <a:solidFill>
@@ -5721,11 +5721,11 @@
         <p:spPr>
           <a:xfrm>
             <a:off x="4343400" y="1645920"/>
-            <a:ext cx="3520440" cy="2240280"/>
+            <a:ext cx="3520440" cy="2468880"/>
           </a:xfrm>
           <a:prstGeom prst="roundRect">
             <a:avLst>
-              <a:gd name="adj" fmla="val 4898"/>
+              <a:gd name="adj" fmla="val 4444"/>
             </a:avLst>
           </a:prstGeom>
           <a:solidFill>
@@ -5855,11 +5855,11 @@
         <p:spPr>
           <a:xfrm>
             <a:off x="8138160" y="1645920"/>
-            <a:ext cx="3520440" cy="2240280"/>
+            <a:ext cx="3520440" cy="2468880"/>
           </a:xfrm>
           <a:prstGeom prst="roundRect">
             <a:avLst>
-              <a:gd name="adj" fmla="val 4898"/>
+              <a:gd name="adj" fmla="val 4444"/>
             </a:avLst>
           </a:prstGeom>
           <a:solidFill>
@@ -5982,61 +5982,14 @@
       </p:sp>
       <p:sp>
         <p:nvSpPr>
-          <p:cNvPr id="15" name="costo-proy"/>
+          <p:cNvPr id="15" name="links"/>
           <p:cNvSpPr txBox="1"/>
           <p:nvPr/>
         </p:nvSpPr>
         <p:spPr>
           <a:xfrm>
-            <a:off x="548640" y="4206240"/>
-            <a:ext cx="11064240" cy="640080"/>
-          </a:xfrm>
-          <a:prstGeom prst="rect">
-            <a:avLst/>
-          </a:prstGeom>
-          <a:noFill/>
-          <a:ln/>
-        </p:spPr>
-        <p:txBody>
-          <a:bodyPr wrap="square" lIns="0" tIns="0" rIns="0" bIns="0" rtlCol="0" anchor="t"/>
-          <a:lstStyle/>
-          <a:p>
-            <a:pPr indent="0" marL="0">
-              <a:buNone/>
-            </a:pPr>
-            <a:r>
-              <a:rPr lang="en-US" sz="1600" b="1" dirty="0">
-                <a:solidFill>
-                  <a:schemeClr val="accent3"/>
-                </a:solidFill>
-              </a:rPr>
-              <a:t>Costo del proyecto: </a:t>
-            </a:r>
-            <a:pPr indent="0" marL="0">
-              <a:buNone/>
-            </a:pPr>
-            <a:r>
-              <a:rPr lang="en-US" sz="1600" dirty="0">
-                <a:solidFill>
-                  <a:schemeClr val="bg1"/>
-                </a:solidFill>
-              </a:rPr>
-              <a:t>2 meses con un analista y un desarrollador a media jornada ≈ USD 5.600; primer año ≈ USD 8.600. Se recupera reteniendo 8 Golden.</a:t>
-            </a:r>
-            <a:endParaRPr lang="en-US" sz="1600" dirty="0"/>
-          </a:p>
-        </p:txBody>
-      </p:sp>
-      <p:sp>
-        <p:nvSpPr>
-          <p:cNvPr id="16" name="links"/>
-          <p:cNvSpPr txBox="1"/>
-          <p:nvPr/>
-        </p:nvSpPr>
-        <p:spPr>
-          <a:xfrm>
-            <a:off x="548640" y="4892040"/>
-            <a:ext cx="11064240" cy="777240"/>
+            <a:off x="548640" y="4572000"/>
+            <a:ext cx="11064240" cy="914400"/>
           </a:xfrm>
           <a:prstGeom prst="rect">
             <a:avLst/>
@@ -6127,7 +6080,7 @@
       </p:sp>
       <p:sp>
         <p:nvSpPr>
-          <p:cNvPr id="17" name="gracias"/>
+          <p:cNvPr id="16" name="gracias"/>
           <p:cNvSpPr txBox="1"/>
           <p:nvPr/>
         </p:nvSpPr>
@@ -10413,29 +10366,12 @@
               <a:buNone/>
             </a:pPr>
             <a:r>
-              <a:rPr lang="en-US" sz="1400" b="1" dirty="0">
+              <a:rPr lang="en-US" sz="1400" dirty="0">
                 <a:solidFill>
                   <a:schemeClr val="bg1"/>
                 </a:solidFill>
               </a:rPr>
-              <a:t>Costo de retener &lt; valor Golden − valor nuevo + CAC</a:t>
-            </a:r>
-            <a:endParaRPr lang="en-US" sz="1500" dirty="0"/>
-          </a:p>
-          <a:p>
-            <a:pPr indent="0" marL="0">
-              <a:spcAft>
-                <a:spcPts val="400"/>
-              </a:spcAft>
-              <a:buNone/>
-            </a:pPr>
-            <a:r>
-              <a:rPr lang="en-US" sz="1400" dirty="0">
-                <a:solidFill>
-                  <a:schemeClr val="bg1"/>
-                </a:solidFill>
-              </a:rPr>
-              <a:t>= 2.135 − 1.581 + 300 (CAC genérico) = 2,8 veces el CAC</a:t>
+              <a:t>Conseguir un cliente nuevo (CAC genérico): USD 300. Un Golden vale USD 2.135; un cliente nuevo promedio, USD 1.581.</a:t>
             </a:r>
             <a:endParaRPr lang="en-US" sz="1500" dirty="0"/>
           </a:p>

</xml_diff>